<commit_message>
feat : 회원 리스트 ids 조회 API
</commit_message>
<xml_diff>
--- a/msa-ppt/3.데이터 조회 API 구현.pptx
+++ b/msa-ppt/3.데이터 조회 API 구현.pptx
@@ -29,6 +29,9 @@
     <p:sldId id="278" r:id="rId23"/>
     <p:sldId id="279" r:id="rId24"/>
     <p:sldId id="280" r:id="rId25"/>
+    <p:sldId id="281" r:id="rId26"/>
+    <p:sldId id="282" r:id="rId27"/>
+    <p:sldId id="283" r:id="rId28"/>
   </p:sldIdLst>
   <p:sldSz cx="12192000" cy="6858000"/>
   <p:notesSz cx="6858000" cy="9144000"/>
@@ -176,6 +179,13 @@
             <p14:sldId id="278"/>
             <p14:sldId id="279"/>
             <p14:sldId id="280"/>
+          </p14:sldIdLst>
+        </p14:section>
+        <p14:section name="회원 정보 리스트 조회 API" id="{2299C0B9-43B4-4183-B696-6A18A34DE164}">
+          <p14:sldIdLst>
+            <p14:sldId id="281"/>
+            <p14:sldId id="282"/>
+            <p14:sldId id="283"/>
           </p14:sldIdLst>
         </p14:section>
       </p14:sectionLst>
@@ -18788,6 +18798,1888 @@
 </p:sld>
 </file>
 
+<file path=ppt/slides/slide25.xml><?xml version="1.0" encoding="utf-8"?>
+<p:sld xmlns:a="http://schemas.openxmlformats.org/drawingml/2006/main" xmlns:r="http://schemas.openxmlformats.org/officeDocument/2006/relationships" xmlns:p="http://schemas.openxmlformats.org/presentationml/2006/main">
+  <p:cSld>
+    <p:spTree>
+      <p:nvGrpSpPr>
+        <p:cNvPr id="1" name=""/>
+        <p:cNvGrpSpPr/>
+        <p:nvPr/>
+      </p:nvGrpSpPr>
+      <p:grpSpPr>
+        <a:xfrm>
+          <a:off x="0" y="0"/>
+          <a:ext cx="0" cy="0"/>
+          <a:chOff x="0" y="0"/>
+          <a:chExt cx="0" cy="0"/>
+        </a:xfrm>
+      </p:grpSpPr>
+      <p:sp>
+        <p:nvSpPr>
+          <p:cNvPr id="2" name="제목 1">
+            <a:extLst>
+              <a:ext uri="{FF2B5EF4-FFF2-40B4-BE49-F238E27FC236}">
+                <a16:creationId xmlns:a16="http://schemas.microsoft.com/office/drawing/2014/main" id="{BAA3F9CC-8AE9-2BED-2BC7-B263E520A5EC}"/>
+              </a:ext>
+            </a:extLst>
+          </p:cNvPr>
+          <p:cNvSpPr>
+            <a:spLocks noGrp="1"/>
+          </p:cNvSpPr>
+          <p:nvPr>
+            <p:ph type="title"/>
+          </p:nvPr>
+        </p:nvSpPr>
+        <p:spPr/>
+        <p:txBody>
+          <a:bodyPr>
+            <a:normAutofit/>
+          </a:bodyPr>
+          <a:lstStyle/>
+          <a:p>
+            <a:r>
+              <a:rPr lang="ko-KR" altLang="en-US" sz="4000"/>
+              <a:t>회원 </a:t>
+            </a:r>
+            <a:r>
+              <a:rPr lang="en-US" altLang="ko-KR" sz="4000"/>
+              <a:t>ID </a:t>
+            </a:r>
+            <a:r>
+              <a:rPr lang="ko-KR" altLang="en-US" sz="4000"/>
+              <a:t>리스트를 통한 정보조회 </a:t>
+            </a:r>
+            <a:r>
+              <a:rPr lang="en-US" altLang="ko-KR" sz="4000"/>
+              <a:t>- UserService</a:t>
+            </a:r>
+            <a:endParaRPr lang="ko-KR" altLang="en-US" sz="4000"/>
+          </a:p>
+        </p:txBody>
+      </p:sp>
+      <p:sp>
+        <p:nvSpPr>
+          <p:cNvPr id="4" name="TextBox 3">
+            <a:extLst>
+              <a:ext uri="{FF2B5EF4-FFF2-40B4-BE49-F238E27FC236}">
+                <a16:creationId xmlns:a16="http://schemas.microsoft.com/office/drawing/2014/main" id="{E95CE448-FDA4-8E06-5EF4-D0DCB00C56B1}"/>
+              </a:ext>
+            </a:extLst>
+          </p:cNvPr>
+          <p:cNvSpPr txBox="1"/>
+          <p:nvPr/>
+        </p:nvSpPr>
+        <p:spPr>
+          <a:xfrm>
+            <a:off x="4016502" y="1940082"/>
+            <a:ext cx="6094476" cy="1708160"/>
+          </a:xfrm>
+          <a:prstGeom prst="rect">
+            <a:avLst/>
+          </a:prstGeom>
+          <a:solidFill>
+            <a:schemeClr val="tx1"/>
+          </a:solidFill>
+        </p:spPr>
+        <p:txBody>
+          <a:bodyPr wrap="square">
+            <a:spAutoFit/>
+          </a:bodyPr>
+          <a:lstStyle/>
+          <a:p>
+            <a:pPr>
+              <a:lnSpc>
+                <a:spcPts val="1425"/>
+              </a:lnSpc>
+              <a:buNone/>
+            </a:pPr>
+            <a:r>
+              <a:rPr lang="en-US" altLang="ko-KR" sz="1200" b="0">
+                <a:solidFill>
+                  <a:srgbClr val="BBBEBF"/>
+                </a:solidFill>
+                <a:effectLst/>
+                <a:latin typeface="Consolas" panose="020B0609020204030204" pitchFamily="49" charset="0"/>
+              </a:rPr>
+              <a:t>    </a:t>
+            </a:r>
+            <a:r>
+              <a:rPr lang="en-US" altLang="ko-KR" sz="1200" b="0">
+                <a:solidFill>
+                  <a:srgbClr val="569CD6"/>
+                </a:solidFill>
+                <a:effectLst/>
+                <a:latin typeface="Consolas" panose="020B0609020204030204" pitchFamily="49" charset="0"/>
+              </a:rPr>
+              <a:t>public</a:t>
+            </a:r>
+            <a:r>
+              <a:rPr lang="en-US" altLang="ko-KR" sz="1200" b="0">
+                <a:solidFill>
+                  <a:srgbClr val="BBBEBF"/>
+                </a:solidFill>
+                <a:effectLst/>
+                <a:latin typeface="Consolas" panose="020B0609020204030204" pitchFamily="49" charset="0"/>
+              </a:rPr>
+              <a:t> </a:t>
+            </a:r>
+            <a:r>
+              <a:rPr lang="en-US" altLang="ko-KR" sz="1200" b="0">
+                <a:solidFill>
+                  <a:srgbClr val="4EC9B0"/>
+                </a:solidFill>
+                <a:effectLst/>
+                <a:latin typeface="Consolas" panose="020B0609020204030204" pitchFamily="49" charset="0"/>
+              </a:rPr>
+              <a:t>List</a:t>
+            </a:r>
+            <a:r>
+              <a:rPr lang="en-US" altLang="ko-KR" sz="1200" b="0">
+                <a:solidFill>
+                  <a:srgbClr val="BBBEBF"/>
+                </a:solidFill>
+                <a:effectLst/>
+                <a:latin typeface="Consolas" panose="020B0609020204030204" pitchFamily="49" charset="0"/>
+              </a:rPr>
+              <a:t>&lt;</a:t>
+            </a:r>
+            <a:r>
+              <a:rPr lang="en-US" altLang="ko-KR" sz="1200" b="0">
+                <a:solidFill>
+                  <a:srgbClr val="4EC9B0"/>
+                </a:solidFill>
+                <a:effectLst/>
+                <a:latin typeface="Consolas" panose="020B0609020204030204" pitchFamily="49" charset="0"/>
+              </a:rPr>
+              <a:t>UserResponseDto</a:t>
+            </a:r>
+            <a:r>
+              <a:rPr lang="en-US" altLang="ko-KR" sz="1200" b="0">
+                <a:solidFill>
+                  <a:srgbClr val="BBBEBF"/>
+                </a:solidFill>
+                <a:effectLst/>
+                <a:latin typeface="Consolas" panose="020B0609020204030204" pitchFamily="49" charset="0"/>
+              </a:rPr>
+              <a:t>&gt; </a:t>
+            </a:r>
+            <a:r>
+              <a:rPr lang="en-US" altLang="ko-KR" sz="1200" b="0">
+                <a:solidFill>
+                  <a:srgbClr val="D2A8FF"/>
+                </a:solidFill>
+                <a:effectLst/>
+                <a:latin typeface="Consolas" panose="020B0609020204030204" pitchFamily="49" charset="0"/>
+              </a:rPr>
+              <a:t>getUsersByIds</a:t>
+            </a:r>
+            <a:r>
+              <a:rPr lang="en-US" altLang="ko-KR" sz="1200" b="0">
+                <a:solidFill>
+                  <a:srgbClr val="BBBEBF"/>
+                </a:solidFill>
+                <a:effectLst/>
+                <a:latin typeface="Consolas" panose="020B0609020204030204" pitchFamily="49" charset="0"/>
+              </a:rPr>
+              <a:t>(</a:t>
+            </a:r>
+            <a:r>
+              <a:rPr lang="en-US" altLang="ko-KR" sz="1200" b="0">
+                <a:solidFill>
+                  <a:srgbClr val="4EC9B0"/>
+                </a:solidFill>
+                <a:effectLst/>
+                <a:latin typeface="Consolas" panose="020B0609020204030204" pitchFamily="49" charset="0"/>
+              </a:rPr>
+              <a:t>List</a:t>
+            </a:r>
+            <a:r>
+              <a:rPr lang="en-US" altLang="ko-KR" sz="1200" b="0">
+                <a:solidFill>
+                  <a:srgbClr val="BBBEBF"/>
+                </a:solidFill>
+                <a:effectLst/>
+                <a:latin typeface="Consolas" panose="020B0609020204030204" pitchFamily="49" charset="0"/>
+              </a:rPr>
+              <a:t>&lt;</a:t>
+            </a:r>
+            <a:r>
+              <a:rPr lang="en-US" altLang="ko-KR" sz="1200" b="0">
+                <a:solidFill>
+                  <a:srgbClr val="4EC9B0"/>
+                </a:solidFill>
+                <a:effectLst/>
+                <a:latin typeface="Consolas" panose="020B0609020204030204" pitchFamily="49" charset="0"/>
+              </a:rPr>
+              <a:t>Long</a:t>
+            </a:r>
+            <a:r>
+              <a:rPr lang="en-US" altLang="ko-KR" sz="1200" b="0">
+                <a:solidFill>
+                  <a:srgbClr val="BBBEBF"/>
+                </a:solidFill>
+                <a:effectLst/>
+                <a:latin typeface="Consolas" panose="020B0609020204030204" pitchFamily="49" charset="0"/>
+              </a:rPr>
+              <a:t>&gt; </a:t>
+            </a:r>
+            <a:r>
+              <a:rPr lang="en-US" altLang="ko-KR" sz="1200" b="0">
+                <a:solidFill>
+                  <a:srgbClr val="FFA657"/>
+                </a:solidFill>
+                <a:effectLst/>
+                <a:latin typeface="Consolas" panose="020B0609020204030204" pitchFamily="49" charset="0"/>
+              </a:rPr>
+              <a:t>ids</a:t>
+            </a:r>
+            <a:r>
+              <a:rPr lang="en-US" altLang="ko-KR" sz="1200" b="0">
+                <a:solidFill>
+                  <a:srgbClr val="BBBEBF"/>
+                </a:solidFill>
+                <a:effectLst/>
+                <a:latin typeface="Consolas" panose="020B0609020204030204" pitchFamily="49" charset="0"/>
+              </a:rPr>
+              <a:t>) {</a:t>
+            </a:r>
+          </a:p>
+          <a:p>
+            <a:pPr>
+              <a:lnSpc>
+                <a:spcPts val="1425"/>
+              </a:lnSpc>
+              <a:buNone/>
+            </a:pPr>
+            <a:r>
+              <a:rPr lang="en-US" altLang="ko-KR" sz="1200" b="0">
+                <a:solidFill>
+                  <a:srgbClr val="BBBEBF"/>
+                </a:solidFill>
+                <a:effectLst/>
+                <a:latin typeface="Consolas" panose="020B0609020204030204" pitchFamily="49" charset="0"/>
+              </a:rPr>
+              <a:t>        </a:t>
+            </a:r>
+            <a:r>
+              <a:rPr lang="en-US" altLang="ko-KR" sz="1200" b="0">
+                <a:solidFill>
+                  <a:srgbClr val="4EC9B0"/>
+                </a:solidFill>
+                <a:effectLst/>
+                <a:latin typeface="Consolas" panose="020B0609020204030204" pitchFamily="49" charset="0"/>
+              </a:rPr>
+              <a:t>List</a:t>
+            </a:r>
+            <a:r>
+              <a:rPr lang="en-US" altLang="ko-KR" sz="1200" b="0">
+                <a:solidFill>
+                  <a:srgbClr val="FFA657"/>
+                </a:solidFill>
+                <a:effectLst/>
+                <a:latin typeface="Consolas" panose="020B0609020204030204" pitchFamily="49" charset="0"/>
+              </a:rPr>
+              <a:t>&lt;</a:t>
+            </a:r>
+            <a:r>
+              <a:rPr lang="en-US" altLang="ko-KR" sz="1200" b="0">
+                <a:solidFill>
+                  <a:srgbClr val="4EC9B0"/>
+                </a:solidFill>
+                <a:effectLst/>
+                <a:latin typeface="Consolas" panose="020B0609020204030204" pitchFamily="49" charset="0"/>
+              </a:rPr>
+              <a:t>User</a:t>
+            </a:r>
+            <a:r>
+              <a:rPr lang="en-US" altLang="ko-KR" sz="1200" b="0">
+                <a:solidFill>
+                  <a:srgbClr val="FFA657"/>
+                </a:solidFill>
+                <a:effectLst/>
+                <a:latin typeface="Consolas" panose="020B0609020204030204" pitchFamily="49" charset="0"/>
+              </a:rPr>
+              <a:t>&gt; </a:t>
+            </a:r>
+            <a:r>
+              <a:rPr lang="en-US" altLang="ko-KR" sz="1200" b="0">
+                <a:solidFill>
+                  <a:srgbClr val="C9D1D9"/>
+                </a:solidFill>
+                <a:effectLst/>
+                <a:latin typeface="Consolas" panose="020B0609020204030204" pitchFamily="49" charset="0"/>
+              </a:rPr>
+              <a:t>users</a:t>
+            </a:r>
+            <a:r>
+              <a:rPr lang="en-US" altLang="ko-KR" sz="1200" b="0">
+                <a:solidFill>
+                  <a:srgbClr val="FFA657"/>
+                </a:solidFill>
+                <a:effectLst/>
+                <a:latin typeface="Consolas" panose="020B0609020204030204" pitchFamily="49" charset="0"/>
+              </a:rPr>
+              <a:t> </a:t>
+            </a:r>
+            <a:r>
+              <a:rPr lang="en-US" altLang="ko-KR" sz="1200" b="0">
+                <a:solidFill>
+                  <a:srgbClr val="D4D4D4"/>
+                </a:solidFill>
+                <a:effectLst/>
+                <a:latin typeface="Consolas" panose="020B0609020204030204" pitchFamily="49" charset="0"/>
+              </a:rPr>
+              <a:t>=</a:t>
+            </a:r>
+            <a:r>
+              <a:rPr lang="en-US" altLang="ko-KR" sz="1200" b="0">
+                <a:solidFill>
+                  <a:srgbClr val="BBBEBF"/>
+                </a:solidFill>
+                <a:effectLst/>
+                <a:latin typeface="Consolas" panose="020B0609020204030204" pitchFamily="49" charset="0"/>
+              </a:rPr>
+              <a:t> </a:t>
+            </a:r>
+            <a:r>
+              <a:rPr lang="en-US" altLang="ko-KR" sz="1200" b="0">
+                <a:solidFill>
+                  <a:srgbClr val="79C0FF"/>
+                </a:solidFill>
+                <a:effectLst/>
+                <a:latin typeface="Consolas" panose="020B0609020204030204" pitchFamily="49" charset="0"/>
+              </a:rPr>
+              <a:t>this</a:t>
+            </a:r>
+            <a:r>
+              <a:rPr lang="en-US" altLang="ko-KR" sz="1200" b="0">
+                <a:solidFill>
+                  <a:srgbClr val="BBBEBF"/>
+                </a:solidFill>
+                <a:effectLst/>
+                <a:latin typeface="Consolas" panose="020B0609020204030204" pitchFamily="49" charset="0"/>
+              </a:rPr>
+              <a:t>.</a:t>
+            </a:r>
+            <a:r>
+              <a:rPr lang="en-US" altLang="ko-KR" sz="1200" b="0">
+                <a:solidFill>
+                  <a:srgbClr val="79C0FF"/>
+                </a:solidFill>
+                <a:effectLst/>
+                <a:latin typeface="Consolas" panose="020B0609020204030204" pitchFamily="49" charset="0"/>
+              </a:rPr>
+              <a:t>userRepository</a:t>
+            </a:r>
+            <a:r>
+              <a:rPr lang="en-US" altLang="ko-KR" sz="1200" b="0">
+                <a:solidFill>
+                  <a:srgbClr val="BBBEBF"/>
+                </a:solidFill>
+                <a:effectLst/>
+                <a:latin typeface="Consolas" panose="020B0609020204030204" pitchFamily="49" charset="0"/>
+              </a:rPr>
+              <a:t>.</a:t>
+            </a:r>
+            <a:r>
+              <a:rPr lang="en-US" altLang="ko-KR" sz="1200" b="0">
+                <a:solidFill>
+                  <a:srgbClr val="D2A8FF"/>
+                </a:solidFill>
+                <a:effectLst/>
+                <a:latin typeface="Consolas" panose="020B0609020204030204" pitchFamily="49" charset="0"/>
+              </a:rPr>
+              <a:t>findAllById</a:t>
+            </a:r>
+            <a:r>
+              <a:rPr lang="en-US" altLang="ko-KR" sz="1200" b="0">
+                <a:solidFill>
+                  <a:srgbClr val="BBBEBF"/>
+                </a:solidFill>
+                <a:effectLst/>
+                <a:latin typeface="Consolas" panose="020B0609020204030204" pitchFamily="49" charset="0"/>
+              </a:rPr>
+              <a:t>(</a:t>
+            </a:r>
+            <a:r>
+              <a:rPr lang="en-US" altLang="ko-KR" sz="1200" b="0">
+                <a:solidFill>
+                  <a:srgbClr val="FFA657"/>
+                </a:solidFill>
+                <a:effectLst/>
+                <a:latin typeface="Consolas" panose="020B0609020204030204" pitchFamily="49" charset="0"/>
+              </a:rPr>
+              <a:t>ids</a:t>
+            </a:r>
+            <a:r>
+              <a:rPr lang="en-US" altLang="ko-KR" sz="1200" b="0">
+                <a:solidFill>
+                  <a:srgbClr val="BBBEBF"/>
+                </a:solidFill>
+                <a:effectLst/>
+                <a:latin typeface="Consolas" panose="020B0609020204030204" pitchFamily="49" charset="0"/>
+              </a:rPr>
+              <a:t>);</a:t>
+            </a:r>
+          </a:p>
+          <a:p>
+            <a:pPr>
+              <a:lnSpc>
+                <a:spcPts val="1425"/>
+              </a:lnSpc>
+              <a:buNone/>
+            </a:pPr>
+            <a:r>
+              <a:rPr lang="en-US" altLang="ko-KR" sz="1200" b="0">
+                <a:solidFill>
+                  <a:srgbClr val="BBBEBF"/>
+                </a:solidFill>
+                <a:effectLst/>
+                <a:latin typeface="Consolas" panose="020B0609020204030204" pitchFamily="49" charset="0"/>
+              </a:rPr>
+              <a:t>        </a:t>
+            </a:r>
+            <a:r>
+              <a:rPr lang="en-US" altLang="ko-KR" sz="1200" b="0">
+                <a:solidFill>
+                  <a:srgbClr val="C586C0"/>
+                </a:solidFill>
+                <a:effectLst/>
+                <a:latin typeface="Consolas" panose="020B0609020204030204" pitchFamily="49" charset="0"/>
+              </a:rPr>
+              <a:t>return</a:t>
+            </a:r>
+            <a:r>
+              <a:rPr lang="en-US" altLang="ko-KR" sz="1200" b="0">
+                <a:solidFill>
+                  <a:srgbClr val="BBBEBF"/>
+                </a:solidFill>
+                <a:effectLst/>
+                <a:latin typeface="Consolas" panose="020B0609020204030204" pitchFamily="49" charset="0"/>
+              </a:rPr>
+              <a:t> </a:t>
+            </a:r>
+            <a:r>
+              <a:rPr lang="en-US" altLang="ko-KR" sz="1200" b="0">
+                <a:solidFill>
+                  <a:srgbClr val="C9D1D9"/>
+                </a:solidFill>
+                <a:effectLst/>
+                <a:latin typeface="Consolas" panose="020B0609020204030204" pitchFamily="49" charset="0"/>
+              </a:rPr>
+              <a:t>users</a:t>
+            </a:r>
+            <a:r>
+              <a:rPr lang="en-US" altLang="ko-KR" sz="1200" b="0">
+                <a:solidFill>
+                  <a:srgbClr val="BBBEBF"/>
+                </a:solidFill>
+                <a:effectLst/>
+                <a:latin typeface="Consolas" panose="020B0609020204030204" pitchFamily="49" charset="0"/>
+              </a:rPr>
+              <a:t>.</a:t>
+            </a:r>
+            <a:r>
+              <a:rPr lang="en-US" altLang="ko-KR" sz="1200" b="0">
+                <a:solidFill>
+                  <a:srgbClr val="D2A8FF"/>
+                </a:solidFill>
+                <a:effectLst/>
+                <a:latin typeface="Consolas" panose="020B0609020204030204" pitchFamily="49" charset="0"/>
+              </a:rPr>
+              <a:t>stream</a:t>
+            </a:r>
+            <a:r>
+              <a:rPr lang="en-US" altLang="ko-KR" sz="1200" b="0">
+                <a:solidFill>
+                  <a:srgbClr val="BBBEBF"/>
+                </a:solidFill>
+                <a:effectLst/>
+                <a:latin typeface="Consolas" panose="020B0609020204030204" pitchFamily="49" charset="0"/>
+              </a:rPr>
+              <a:t>()</a:t>
+            </a:r>
+          </a:p>
+          <a:p>
+            <a:pPr>
+              <a:lnSpc>
+                <a:spcPts val="1425"/>
+              </a:lnSpc>
+              <a:buNone/>
+            </a:pPr>
+            <a:r>
+              <a:rPr lang="en-US" altLang="ko-KR" sz="1200" b="0">
+                <a:solidFill>
+                  <a:srgbClr val="BBBEBF"/>
+                </a:solidFill>
+                <a:effectLst/>
+                <a:latin typeface="Consolas" panose="020B0609020204030204" pitchFamily="49" charset="0"/>
+              </a:rPr>
+              <a:t>            .</a:t>
+            </a:r>
+            <a:r>
+              <a:rPr lang="en-US" altLang="ko-KR" sz="1200" b="0">
+                <a:solidFill>
+                  <a:srgbClr val="D2A8FF"/>
+                </a:solidFill>
+                <a:effectLst/>
+                <a:latin typeface="Consolas" panose="020B0609020204030204" pitchFamily="49" charset="0"/>
+              </a:rPr>
+              <a:t>map</a:t>
+            </a:r>
+            <a:r>
+              <a:rPr lang="en-US" altLang="ko-KR" sz="1200" b="0">
+                <a:solidFill>
+                  <a:srgbClr val="BBBEBF"/>
+                </a:solidFill>
+                <a:effectLst/>
+                <a:latin typeface="Consolas" panose="020B0609020204030204" pitchFamily="49" charset="0"/>
+              </a:rPr>
+              <a:t>(</a:t>
+            </a:r>
+            <a:r>
+              <a:rPr lang="en-US" altLang="ko-KR" sz="1200" b="0">
+                <a:solidFill>
+                  <a:srgbClr val="FFA657"/>
+                </a:solidFill>
+                <a:effectLst/>
+                <a:latin typeface="Consolas" panose="020B0609020204030204" pitchFamily="49" charset="0"/>
+              </a:rPr>
+              <a:t>user</a:t>
+            </a:r>
+            <a:r>
+              <a:rPr lang="en-US" altLang="ko-KR" sz="1200" b="0">
+                <a:solidFill>
+                  <a:srgbClr val="BBBEBF"/>
+                </a:solidFill>
+                <a:effectLst/>
+                <a:latin typeface="Consolas" panose="020B0609020204030204" pitchFamily="49" charset="0"/>
+              </a:rPr>
+              <a:t> </a:t>
+            </a:r>
+            <a:r>
+              <a:rPr lang="en-US" altLang="ko-KR" sz="1200" b="0">
+                <a:solidFill>
+                  <a:srgbClr val="FF7B72"/>
+                </a:solidFill>
+                <a:effectLst/>
+                <a:latin typeface="Consolas" panose="020B0609020204030204" pitchFamily="49" charset="0"/>
+              </a:rPr>
+              <a:t>-&gt;</a:t>
+            </a:r>
+            <a:r>
+              <a:rPr lang="en-US" altLang="ko-KR" sz="1200" b="0">
+                <a:solidFill>
+                  <a:srgbClr val="BBBEBF"/>
+                </a:solidFill>
+                <a:effectLst/>
+                <a:latin typeface="Consolas" panose="020B0609020204030204" pitchFamily="49" charset="0"/>
+              </a:rPr>
+              <a:t> </a:t>
+            </a:r>
+            <a:r>
+              <a:rPr lang="en-US" altLang="ko-KR" sz="1200" b="0">
+                <a:solidFill>
+                  <a:srgbClr val="C586C0"/>
+                </a:solidFill>
+                <a:effectLst/>
+                <a:latin typeface="Consolas" panose="020B0609020204030204" pitchFamily="49" charset="0"/>
+              </a:rPr>
+              <a:t>new</a:t>
+            </a:r>
+            <a:r>
+              <a:rPr lang="en-US" altLang="ko-KR" sz="1200" b="0">
+                <a:solidFill>
+                  <a:srgbClr val="BBBEBF"/>
+                </a:solidFill>
+                <a:effectLst/>
+                <a:latin typeface="Consolas" panose="020B0609020204030204" pitchFamily="49" charset="0"/>
+              </a:rPr>
+              <a:t> </a:t>
+            </a:r>
+            <a:r>
+              <a:rPr lang="en-US" altLang="ko-KR" sz="1200" b="0">
+                <a:solidFill>
+                  <a:srgbClr val="D2A8FF"/>
+                </a:solidFill>
+                <a:effectLst/>
+                <a:latin typeface="Consolas" panose="020B0609020204030204" pitchFamily="49" charset="0"/>
+              </a:rPr>
+              <a:t>UserResponseDto</a:t>
+            </a:r>
+            <a:r>
+              <a:rPr lang="en-US" altLang="ko-KR" sz="1200" b="0">
+                <a:solidFill>
+                  <a:srgbClr val="BBBEBF"/>
+                </a:solidFill>
+                <a:effectLst/>
+                <a:latin typeface="Consolas" panose="020B0609020204030204" pitchFamily="49" charset="0"/>
+              </a:rPr>
+              <a:t>(</a:t>
+            </a:r>
+          </a:p>
+          <a:p>
+            <a:pPr>
+              <a:lnSpc>
+                <a:spcPts val="1425"/>
+              </a:lnSpc>
+              <a:buNone/>
+            </a:pPr>
+            <a:r>
+              <a:rPr lang="en-US" altLang="ko-KR" sz="1200" b="0">
+                <a:solidFill>
+                  <a:srgbClr val="BBBEBF"/>
+                </a:solidFill>
+                <a:effectLst/>
+                <a:latin typeface="Consolas" panose="020B0609020204030204" pitchFamily="49" charset="0"/>
+              </a:rPr>
+              <a:t>                </a:t>
+            </a:r>
+            <a:r>
+              <a:rPr lang="en-US" altLang="ko-KR" sz="1200" b="0">
+                <a:solidFill>
+                  <a:srgbClr val="FFA657"/>
+                </a:solidFill>
+                <a:effectLst/>
+                <a:latin typeface="Consolas" panose="020B0609020204030204" pitchFamily="49" charset="0"/>
+              </a:rPr>
+              <a:t>user</a:t>
+            </a:r>
+            <a:r>
+              <a:rPr lang="en-US" altLang="ko-KR" sz="1200" b="0">
+                <a:solidFill>
+                  <a:srgbClr val="BBBEBF"/>
+                </a:solidFill>
+                <a:effectLst/>
+                <a:latin typeface="Consolas" panose="020B0609020204030204" pitchFamily="49" charset="0"/>
+              </a:rPr>
+              <a:t>.</a:t>
+            </a:r>
+            <a:r>
+              <a:rPr lang="en-US" altLang="ko-KR" sz="1200" b="0">
+                <a:solidFill>
+                  <a:srgbClr val="D2A8FF"/>
+                </a:solidFill>
+                <a:effectLst/>
+                <a:latin typeface="Consolas" panose="020B0609020204030204" pitchFamily="49" charset="0"/>
+              </a:rPr>
+              <a:t>getUserId</a:t>
+            </a:r>
+            <a:r>
+              <a:rPr lang="en-US" altLang="ko-KR" sz="1200" b="0">
+                <a:solidFill>
+                  <a:srgbClr val="BBBEBF"/>
+                </a:solidFill>
+                <a:effectLst/>
+                <a:latin typeface="Consolas" panose="020B0609020204030204" pitchFamily="49" charset="0"/>
+              </a:rPr>
+              <a:t>(),</a:t>
+            </a:r>
+          </a:p>
+          <a:p>
+            <a:pPr>
+              <a:lnSpc>
+                <a:spcPts val="1425"/>
+              </a:lnSpc>
+              <a:buNone/>
+            </a:pPr>
+            <a:r>
+              <a:rPr lang="en-US" altLang="ko-KR" sz="1200" b="0">
+                <a:solidFill>
+                  <a:srgbClr val="BBBEBF"/>
+                </a:solidFill>
+                <a:effectLst/>
+                <a:latin typeface="Consolas" panose="020B0609020204030204" pitchFamily="49" charset="0"/>
+              </a:rPr>
+              <a:t>                </a:t>
+            </a:r>
+            <a:r>
+              <a:rPr lang="en-US" altLang="ko-KR" sz="1200" b="0">
+                <a:solidFill>
+                  <a:srgbClr val="FFA657"/>
+                </a:solidFill>
+                <a:effectLst/>
+                <a:latin typeface="Consolas" panose="020B0609020204030204" pitchFamily="49" charset="0"/>
+              </a:rPr>
+              <a:t>user</a:t>
+            </a:r>
+            <a:r>
+              <a:rPr lang="en-US" altLang="ko-KR" sz="1200" b="0">
+                <a:solidFill>
+                  <a:srgbClr val="BBBEBF"/>
+                </a:solidFill>
+                <a:effectLst/>
+                <a:latin typeface="Consolas" panose="020B0609020204030204" pitchFamily="49" charset="0"/>
+              </a:rPr>
+              <a:t>.</a:t>
+            </a:r>
+            <a:r>
+              <a:rPr lang="en-US" altLang="ko-KR" sz="1200" b="0">
+                <a:solidFill>
+                  <a:srgbClr val="D2A8FF"/>
+                </a:solidFill>
+                <a:effectLst/>
+                <a:latin typeface="Consolas" panose="020B0609020204030204" pitchFamily="49" charset="0"/>
+              </a:rPr>
+              <a:t>getEmail</a:t>
+            </a:r>
+            <a:r>
+              <a:rPr lang="en-US" altLang="ko-KR" sz="1200" b="0">
+                <a:solidFill>
+                  <a:srgbClr val="BBBEBF"/>
+                </a:solidFill>
+                <a:effectLst/>
+                <a:latin typeface="Consolas" panose="020B0609020204030204" pitchFamily="49" charset="0"/>
+              </a:rPr>
+              <a:t>(),</a:t>
+            </a:r>
+          </a:p>
+          <a:p>
+            <a:pPr>
+              <a:lnSpc>
+                <a:spcPts val="1425"/>
+              </a:lnSpc>
+              <a:buNone/>
+            </a:pPr>
+            <a:r>
+              <a:rPr lang="en-US" altLang="ko-KR" sz="1200" b="0">
+                <a:solidFill>
+                  <a:srgbClr val="BBBEBF"/>
+                </a:solidFill>
+                <a:effectLst/>
+                <a:latin typeface="Consolas" panose="020B0609020204030204" pitchFamily="49" charset="0"/>
+              </a:rPr>
+              <a:t>                </a:t>
+            </a:r>
+            <a:r>
+              <a:rPr lang="en-US" altLang="ko-KR" sz="1200" b="0">
+                <a:solidFill>
+                  <a:srgbClr val="FFA657"/>
+                </a:solidFill>
+                <a:effectLst/>
+                <a:latin typeface="Consolas" panose="020B0609020204030204" pitchFamily="49" charset="0"/>
+              </a:rPr>
+              <a:t>user</a:t>
+            </a:r>
+            <a:r>
+              <a:rPr lang="en-US" altLang="ko-KR" sz="1200" b="0">
+                <a:solidFill>
+                  <a:srgbClr val="BBBEBF"/>
+                </a:solidFill>
+                <a:effectLst/>
+                <a:latin typeface="Consolas" panose="020B0609020204030204" pitchFamily="49" charset="0"/>
+              </a:rPr>
+              <a:t>.</a:t>
+            </a:r>
+            <a:r>
+              <a:rPr lang="en-US" altLang="ko-KR" sz="1200" b="0">
+                <a:solidFill>
+                  <a:srgbClr val="D2A8FF"/>
+                </a:solidFill>
+                <a:effectLst/>
+                <a:latin typeface="Consolas" panose="020B0609020204030204" pitchFamily="49" charset="0"/>
+              </a:rPr>
+              <a:t>getName</a:t>
+            </a:r>
+            <a:r>
+              <a:rPr lang="en-US" altLang="ko-KR" sz="1200" b="0">
+                <a:solidFill>
+                  <a:srgbClr val="BBBEBF"/>
+                </a:solidFill>
+                <a:effectLst/>
+                <a:latin typeface="Consolas" panose="020B0609020204030204" pitchFamily="49" charset="0"/>
+              </a:rPr>
+              <a:t>()</a:t>
+            </a:r>
+          </a:p>
+          <a:p>
+            <a:pPr>
+              <a:lnSpc>
+                <a:spcPts val="1425"/>
+              </a:lnSpc>
+              <a:buNone/>
+            </a:pPr>
+            <a:r>
+              <a:rPr lang="en-US" altLang="ko-KR" sz="1200" b="0">
+                <a:solidFill>
+                  <a:srgbClr val="BBBEBF"/>
+                </a:solidFill>
+                <a:effectLst/>
+                <a:latin typeface="Consolas" panose="020B0609020204030204" pitchFamily="49" charset="0"/>
+              </a:rPr>
+              <a:t>            )).</a:t>
+            </a:r>
+            <a:r>
+              <a:rPr lang="en-US" altLang="ko-KR" sz="1200" b="0">
+                <a:solidFill>
+                  <a:srgbClr val="D2A8FF"/>
+                </a:solidFill>
+                <a:effectLst/>
+                <a:latin typeface="Consolas" panose="020B0609020204030204" pitchFamily="49" charset="0"/>
+              </a:rPr>
+              <a:t>toList</a:t>
+            </a:r>
+            <a:r>
+              <a:rPr lang="en-US" altLang="ko-KR" sz="1200" b="0">
+                <a:solidFill>
+                  <a:srgbClr val="BBBEBF"/>
+                </a:solidFill>
+                <a:effectLst/>
+                <a:latin typeface="Consolas" panose="020B0609020204030204" pitchFamily="49" charset="0"/>
+              </a:rPr>
+              <a:t>();</a:t>
+            </a:r>
+          </a:p>
+          <a:p>
+            <a:pPr>
+              <a:lnSpc>
+                <a:spcPts val="1425"/>
+              </a:lnSpc>
+              <a:buNone/>
+            </a:pPr>
+            <a:r>
+              <a:rPr lang="en-US" altLang="ko-KR" sz="1200" b="0">
+                <a:solidFill>
+                  <a:srgbClr val="BBBEBF"/>
+                </a:solidFill>
+                <a:effectLst/>
+                <a:latin typeface="Consolas" panose="020B0609020204030204" pitchFamily="49" charset="0"/>
+              </a:rPr>
+              <a:t>    }</a:t>
+            </a:r>
+          </a:p>
+        </p:txBody>
+      </p:sp>
+      <p:grpSp>
+        <p:nvGrpSpPr>
+          <p:cNvPr id="8" name="그룹 7">
+            <a:extLst>
+              <a:ext uri="{FF2B5EF4-FFF2-40B4-BE49-F238E27FC236}">
+                <a16:creationId xmlns:a16="http://schemas.microsoft.com/office/drawing/2014/main" id="{D09C8D62-2497-9329-4D7F-C2ED820A4F59}"/>
+              </a:ext>
+            </a:extLst>
+          </p:cNvPr>
+          <p:cNvGrpSpPr/>
+          <p:nvPr/>
+        </p:nvGrpSpPr>
+        <p:grpSpPr>
+          <a:xfrm>
+            <a:off x="982783" y="1940082"/>
+            <a:ext cx="2819794" cy="3296110"/>
+            <a:chOff x="982783" y="1940082"/>
+            <a:chExt cx="2819794" cy="3296110"/>
+          </a:xfrm>
+        </p:grpSpPr>
+        <p:pic>
+          <p:nvPicPr>
+            <p:cNvPr id="6" name="그림 5">
+              <a:extLst>
+                <a:ext uri="{FF2B5EF4-FFF2-40B4-BE49-F238E27FC236}">
+                  <a16:creationId xmlns:a16="http://schemas.microsoft.com/office/drawing/2014/main" id="{1AA5E39A-0325-D435-E0C6-1E4E07EFAEB2}"/>
+                </a:ext>
+              </a:extLst>
+            </p:cNvPr>
+            <p:cNvPicPr>
+              <a:picLocks noChangeAspect="1"/>
+            </p:cNvPicPr>
+            <p:nvPr/>
+          </p:nvPicPr>
+          <p:blipFill>
+            <a:blip r:embed="rId2"/>
+            <a:stretch>
+              <a:fillRect/>
+            </a:stretch>
+          </p:blipFill>
+          <p:spPr>
+            <a:xfrm>
+              <a:off x="982783" y="1940082"/>
+              <a:ext cx="2819794" cy="3296110"/>
+            </a:xfrm>
+            <a:prstGeom prst="rect">
+              <a:avLst/>
+            </a:prstGeom>
+          </p:spPr>
+        </p:pic>
+        <p:sp>
+          <p:nvSpPr>
+            <p:cNvPr id="7" name="직사각형 6">
+              <a:extLst>
+                <a:ext uri="{FF2B5EF4-FFF2-40B4-BE49-F238E27FC236}">
+                  <a16:creationId xmlns:a16="http://schemas.microsoft.com/office/drawing/2014/main" id="{102CD480-4B9F-7B8F-C67F-FD97E96C1D4C}"/>
+                </a:ext>
+              </a:extLst>
+            </p:cNvPr>
+            <p:cNvSpPr/>
+            <p:nvPr/>
+          </p:nvSpPr>
+          <p:spPr>
+            <a:xfrm>
+              <a:off x="1325880" y="4727448"/>
+              <a:ext cx="1234440" cy="256032"/>
+            </a:xfrm>
+            <a:prstGeom prst="rect">
+              <a:avLst/>
+            </a:prstGeom>
+            <a:noFill/>
+            <a:ln>
+              <a:solidFill>
+                <a:srgbClr val="FF0000"/>
+              </a:solidFill>
+            </a:ln>
+          </p:spPr>
+          <p:style>
+            <a:lnRef idx="2">
+              <a:schemeClr val="accent1">
+                <a:shade val="15000"/>
+              </a:schemeClr>
+            </a:lnRef>
+            <a:fillRef idx="1">
+              <a:schemeClr val="accent1"/>
+            </a:fillRef>
+            <a:effectRef idx="0">
+              <a:schemeClr val="accent1"/>
+            </a:effectRef>
+            <a:fontRef idx="minor">
+              <a:schemeClr val="lt1"/>
+            </a:fontRef>
+          </p:style>
+          <p:txBody>
+            <a:bodyPr rtlCol="0" anchor="ctr"/>
+            <a:lstStyle/>
+            <a:p>
+              <a:pPr algn="ctr"/>
+              <a:endParaRPr lang="ko-KR" altLang="en-US"/>
+            </a:p>
+          </p:txBody>
+        </p:sp>
+      </p:grpSp>
+    </p:spTree>
+    <p:extLst>
+      <p:ext uri="{BB962C8B-B14F-4D97-AF65-F5344CB8AC3E}">
+        <p14:creationId xmlns:p14="http://schemas.microsoft.com/office/powerpoint/2010/main" val="4209423547"/>
+      </p:ext>
+    </p:extLst>
+  </p:cSld>
+  <p:clrMapOvr>
+    <a:masterClrMapping/>
+  </p:clrMapOvr>
+</p:sld>
+</file>
+
+<file path=ppt/slides/slide26.xml><?xml version="1.0" encoding="utf-8"?>
+<p:sld xmlns:a="http://schemas.openxmlformats.org/drawingml/2006/main" xmlns:r="http://schemas.openxmlformats.org/officeDocument/2006/relationships" xmlns:p="http://schemas.openxmlformats.org/presentationml/2006/main">
+  <p:cSld>
+    <p:spTree>
+      <p:nvGrpSpPr>
+        <p:cNvPr id="1" name=""/>
+        <p:cNvGrpSpPr/>
+        <p:nvPr/>
+      </p:nvGrpSpPr>
+      <p:grpSpPr>
+        <a:xfrm>
+          <a:off x="0" y="0"/>
+          <a:ext cx="0" cy="0"/>
+          <a:chOff x="0" y="0"/>
+          <a:chExt cx="0" cy="0"/>
+        </a:xfrm>
+      </p:grpSpPr>
+      <p:sp>
+        <p:nvSpPr>
+          <p:cNvPr id="2" name="제목 1">
+            <a:extLst>
+              <a:ext uri="{FF2B5EF4-FFF2-40B4-BE49-F238E27FC236}">
+                <a16:creationId xmlns:a16="http://schemas.microsoft.com/office/drawing/2014/main" id="{41A1BF73-22DC-3212-EFC7-C82C4C6CF57E}"/>
+              </a:ext>
+            </a:extLst>
+          </p:cNvPr>
+          <p:cNvSpPr>
+            <a:spLocks noGrp="1"/>
+          </p:cNvSpPr>
+          <p:nvPr>
+            <p:ph type="title"/>
+          </p:nvPr>
+        </p:nvSpPr>
+        <p:spPr/>
+        <p:txBody>
+          <a:bodyPr>
+            <a:normAutofit/>
+          </a:bodyPr>
+          <a:lstStyle/>
+          <a:p>
+            <a:r>
+              <a:rPr lang="ko-KR" altLang="en-US" sz="4400"/>
+              <a:t>회원</a:t>
+            </a:r>
+            <a:r>
+              <a:rPr lang="en-US" altLang="ko-KR" sz="4400"/>
+              <a:t>ID</a:t>
+            </a:r>
+            <a:r>
+              <a:rPr lang="ko-KR" altLang="en-US" sz="4400"/>
+              <a:t>리스트를 통한 정보조회</a:t>
+            </a:r>
+            <a:r>
+              <a:rPr lang="en-US" altLang="ko-KR" sz="4400"/>
+              <a:t>-Controller</a:t>
+            </a:r>
+            <a:endParaRPr lang="ko-KR" altLang="en-US" sz="4400"/>
+          </a:p>
+        </p:txBody>
+      </p:sp>
+      <p:grpSp>
+        <p:nvGrpSpPr>
+          <p:cNvPr id="3" name="그룹 2">
+            <a:extLst>
+              <a:ext uri="{FF2B5EF4-FFF2-40B4-BE49-F238E27FC236}">
+                <a16:creationId xmlns:a16="http://schemas.microsoft.com/office/drawing/2014/main" id="{F0EAA9F4-4BC7-4971-C42D-A98EA51947BA}"/>
+              </a:ext>
+            </a:extLst>
+          </p:cNvPr>
+          <p:cNvGrpSpPr/>
+          <p:nvPr/>
+        </p:nvGrpSpPr>
+        <p:grpSpPr>
+          <a:xfrm>
+            <a:off x="982783" y="1940082"/>
+            <a:ext cx="2819794" cy="3296110"/>
+            <a:chOff x="982783" y="1940082"/>
+            <a:chExt cx="2819794" cy="3296110"/>
+          </a:xfrm>
+        </p:grpSpPr>
+        <p:pic>
+          <p:nvPicPr>
+            <p:cNvPr id="4" name="그림 3">
+              <a:extLst>
+                <a:ext uri="{FF2B5EF4-FFF2-40B4-BE49-F238E27FC236}">
+                  <a16:creationId xmlns:a16="http://schemas.microsoft.com/office/drawing/2014/main" id="{EBD5D312-1CAB-6289-53B2-9C0EF88796A0}"/>
+                </a:ext>
+              </a:extLst>
+            </p:cNvPr>
+            <p:cNvPicPr>
+              <a:picLocks noChangeAspect="1"/>
+            </p:cNvPicPr>
+            <p:nvPr/>
+          </p:nvPicPr>
+          <p:blipFill>
+            <a:blip r:embed="rId2"/>
+            <a:stretch>
+              <a:fillRect/>
+            </a:stretch>
+          </p:blipFill>
+          <p:spPr>
+            <a:xfrm>
+              <a:off x="982783" y="1940082"/>
+              <a:ext cx="2819794" cy="3296110"/>
+            </a:xfrm>
+            <a:prstGeom prst="rect">
+              <a:avLst/>
+            </a:prstGeom>
+          </p:spPr>
+        </p:pic>
+        <p:sp>
+          <p:nvSpPr>
+            <p:cNvPr id="5" name="직사각형 4">
+              <a:extLst>
+                <a:ext uri="{FF2B5EF4-FFF2-40B4-BE49-F238E27FC236}">
+                  <a16:creationId xmlns:a16="http://schemas.microsoft.com/office/drawing/2014/main" id="{744FE1F7-D67B-0B87-E2B6-1C618900F19D}"/>
+                </a:ext>
+              </a:extLst>
+            </p:cNvPr>
+            <p:cNvSpPr/>
+            <p:nvPr/>
+          </p:nvSpPr>
+          <p:spPr>
+            <a:xfrm>
+              <a:off x="1353312" y="2852928"/>
+              <a:ext cx="1307592" cy="228600"/>
+            </a:xfrm>
+            <a:prstGeom prst="rect">
+              <a:avLst/>
+            </a:prstGeom>
+            <a:noFill/>
+            <a:ln>
+              <a:solidFill>
+                <a:srgbClr val="FF0000"/>
+              </a:solidFill>
+            </a:ln>
+          </p:spPr>
+          <p:style>
+            <a:lnRef idx="2">
+              <a:schemeClr val="accent1">
+                <a:shade val="15000"/>
+              </a:schemeClr>
+            </a:lnRef>
+            <a:fillRef idx="1">
+              <a:schemeClr val="accent1"/>
+            </a:fillRef>
+            <a:effectRef idx="0">
+              <a:schemeClr val="accent1"/>
+            </a:effectRef>
+            <a:fontRef idx="minor">
+              <a:schemeClr val="lt1"/>
+            </a:fontRef>
+          </p:style>
+          <p:txBody>
+            <a:bodyPr rtlCol="0" anchor="ctr"/>
+            <a:lstStyle/>
+            <a:p>
+              <a:pPr algn="ctr"/>
+              <a:endParaRPr lang="ko-KR" altLang="en-US"/>
+            </a:p>
+          </p:txBody>
+        </p:sp>
+      </p:grpSp>
+      <p:sp>
+        <p:nvSpPr>
+          <p:cNvPr id="9" name="TextBox 8">
+            <a:extLst>
+              <a:ext uri="{FF2B5EF4-FFF2-40B4-BE49-F238E27FC236}">
+                <a16:creationId xmlns:a16="http://schemas.microsoft.com/office/drawing/2014/main" id="{8F9EAED6-F1BF-3237-7342-58DAD03C6270}"/>
+              </a:ext>
+            </a:extLst>
+          </p:cNvPr>
+          <p:cNvSpPr txBox="1"/>
+          <p:nvPr/>
+        </p:nvSpPr>
+        <p:spPr>
+          <a:xfrm>
+            <a:off x="3998214" y="1940082"/>
+            <a:ext cx="6094476" cy="1338828"/>
+          </a:xfrm>
+          <a:prstGeom prst="rect">
+            <a:avLst/>
+          </a:prstGeom>
+          <a:solidFill>
+            <a:schemeClr val="tx1"/>
+          </a:solidFill>
+        </p:spPr>
+        <p:txBody>
+          <a:bodyPr wrap="square">
+            <a:spAutoFit/>
+          </a:bodyPr>
+          <a:lstStyle/>
+          <a:p>
+            <a:pPr>
+              <a:lnSpc>
+                <a:spcPts val="1425"/>
+              </a:lnSpc>
+              <a:buNone/>
+            </a:pPr>
+            <a:r>
+              <a:rPr lang="en-US" altLang="ko-KR" sz="1050" b="0">
+                <a:solidFill>
+                  <a:srgbClr val="BBBEBF"/>
+                </a:solidFill>
+                <a:effectLst/>
+                <a:latin typeface="Consolas" panose="020B0609020204030204" pitchFamily="49" charset="0"/>
+              </a:rPr>
+              <a:t>    @</a:t>
+            </a:r>
+            <a:r>
+              <a:rPr lang="en-US" altLang="ko-KR" sz="1050" b="0">
+                <a:solidFill>
+                  <a:srgbClr val="4EC9B0"/>
+                </a:solidFill>
+                <a:effectLst/>
+                <a:latin typeface="Consolas" panose="020B0609020204030204" pitchFamily="49" charset="0"/>
+              </a:rPr>
+              <a:t>GetMapping</a:t>
+            </a:r>
+            <a:endParaRPr lang="en-US" altLang="ko-KR" sz="1050" b="0">
+              <a:solidFill>
+                <a:srgbClr val="BBBEBF"/>
+              </a:solidFill>
+              <a:effectLst/>
+              <a:latin typeface="Consolas" panose="020B0609020204030204" pitchFamily="49" charset="0"/>
+            </a:endParaRPr>
+          </a:p>
+          <a:p>
+            <a:pPr>
+              <a:lnSpc>
+                <a:spcPts val="1425"/>
+              </a:lnSpc>
+              <a:buNone/>
+            </a:pPr>
+            <a:r>
+              <a:rPr lang="en-US" altLang="ko-KR" sz="1050" b="0">
+                <a:solidFill>
+                  <a:srgbClr val="BBBEBF"/>
+                </a:solidFill>
+                <a:effectLst/>
+                <a:latin typeface="Consolas" panose="020B0609020204030204" pitchFamily="49" charset="0"/>
+              </a:rPr>
+              <a:t>    </a:t>
+            </a:r>
+            <a:r>
+              <a:rPr lang="en-US" altLang="ko-KR" sz="1050" b="0">
+                <a:solidFill>
+                  <a:srgbClr val="569CD6"/>
+                </a:solidFill>
+                <a:effectLst/>
+                <a:latin typeface="Consolas" panose="020B0609020204030204" pitchFamily="49" charset="0"/>
+              </a:rPr>
+              <a:t>public</a:t>
+            </a:r>
+            <a:r>
+              <a:rPr lang="en-US" altLang="ko-KR" sz="1050" b="0">
+                <a:solidFill>
+                  <a:srgbClr val="BBBEBF"/>
+                </a:solidFill>
+                <a:effectLst/>
+                <a:latin typeface="Consolas" panose="020B0609020204030204" pitchFamily="49" charset="0"/>
+              </a:rPr>
+              <a:t> </a:t>
+            </a:r>
+            <a:r>
+              <a:rPr lang="en-US" altLang="ko-KR" sz="1050" b="0">
+                <a:solidFill>
+                  <a:srgbClr val="4EC9B0"/>
+                </a:solidFill>
+                <a:effectLst/>
+                <a:latin typeface="Consolas" panose="020B0609020204030204" pitchFamily="49" charset="0"/>
+              </a:rPr>
+              <a:t>ResponseEntity</a:t>
+            </a:r>
+            <a:r>
+              <a:rPr lang="en-US" altLang="ko-KR" sz="1050" b="0">
+                <a:solidFill>
+                  <a:srgbClr val="BBBEBF"/>
+                </a:solidFill>
+                <a:effectLst/>
+                <a:latin typeface="Consolas" panose="020B0609020204030204" pitchFamily="49" charset="0"/>
+              </a:rPr>
+              <a:t>&lt;</a:t>
+            </a:r>
+            <a:r>
+              <a:rPr lang="en-US" altLang="ko-KR" sz="1050" b="0">
+                <a:solidFill>
+                  <a:srgbClr val="4EC9B0"/>
+                </a:solidFill>
+                <a:effectLst/>
+                <a:latin typeface="Consolas" panose="020B0609020204030204" pitchFamily="49" charset="0"/>
+              </a:rPr>
+              <a:t>List</a:t>
+            </a:r>
+            <a:r>
+              <a:rPr lang="en-US" altLang="ko-KR" sz="1050" b="0">
+                <a:solidFill>
+                  <a:srgbClr val="BBBEBF"/>
+                </a:solidFill>
+                <a:effectLst/>
+                <a:latin typeface="Consolas" panose="020B0609020204030204" pitchFamily="49" charset="0"/>
+              </a:rPr>
+              <a:t>&lt;</a:t>
+            </a:r>
+            <a:r>
+              <a:rPr lang="en-US" altLang="ko-KR" sz="1050" b="0">
+                <a:solidFill>
+                  <a:srgbClr val="4EC9B0"/>
+                </a:solidFill>
+                <a:effectLst/>
+                <a:latin typeface="Consolas" panose="020B0609020204030204" pitchFamily="49" charset="0"/>
+              </a:rPr>
+              <a:t>UserResponseDto</a:t>
+            </a:r>
+            <a:r>
+              <a:rPr lang="en-US" altLang="ko-KR" sz="1050" b="0">
+                <a:solidFill>
+                  <a:srgbClr val="BBBEBF"/>
+                </a:solidFill>
+                <a:effectLst/>
+                <a:latin typeface="Consolas" panose="020B0609020204030204" pitchFamily="49" charset="0"/>
+              </a:rPr>
+              <a:t>&gt;&gt; </a:t>
+            </a:r>
+            <a:r>
+              <a:rPr lang="en-US" altLang="ko-KR" sz="1050" b="0">
+                <a:solidFill>
+                  <a:srgbClr val="D2A8FF"/>
+                </a:solidFill>
+                <a:effectLst/>
+                <a:latin typeface="Consolas" panose="020B0609020204030204" pitchFamily="49" charset="0"/>
+              </a:rPr>
+              <a:t>getUsersByIds</a:t>
+            </a:r>
+            <a:r>
+              <a:rPr lang="en-US" altLang="ko-KR" sz="1050" b="0">
+                <a:solidFill>
+                  <a:srgbClr val="BBBEBF"/>
+                </a:solidFill>
+                <a:effectLst/>
+                <a:latin typeface="Consolas" panose="020B0609020204030204" pitchFamily="49" charset="0"/>
+              </a:rPr>
+              <a:t>(</a:t>
+            </a:r>
+          </a:p>
+          <a:p>
+            <a:pPr>
+              <a:lnSpc>
+                <a:spcPts val="1425"/>
+              </a:lnSpc>
+              <a:buNone/>
+            </a:pPr>
+            <a:r>
+              <a:rPr lang="en-US" altLang="ko-KR" sz="1050" b="0">
+                <a:solidFill>
+                  <a:srgbClr val="BBBEBF"/>
+                </a:solidFill>
+                <a:effectLst/>
+                <a:latin typeface="Consolas" panose="020B0609020204030204" pitchFamily="49" charset="0"/>
+              </a:rPr>
+              <a:t>        @</a:t>
+            </a:r>
+            <a:r>
+              <a:rPr lang="en-US" altLang="ko-KR" sz="1050" b="0">
+                <a:solidFill>
+                  <a:srgbClr val="4EC9B0"/>
+                </a:solidFill>
+                <a:effectLst/>
+                <a:latin typeface="Consolas" panose="020B0609020204030204" pitchFamily="49" charset="0"/>
+              </a:rPr>
+              <a:t>RequestParam</a:t>
+            </a:r>
+            <a:r>
+              <a:rPr lang="en-US" altLang="ko-KR" sz="1050" b="0">
+                <a:solidFill>
+                  <a:srgbClr val="BBBEBF"/>
+                </a:solidFill>
+                <a:effectLst/>
+                <a:latin typeface="Consolas" panose="020B0609020204030204" pitchFamily="49" charset="0"/>
+              </a:rPr>
+              <a:t>(</a:t>
+            </a:r>
+            <a:r>
+              <a:rPr lang="en-US" altLang="ko-KR" sz="1050" b="0">
+                <a:solidFill>
+                  <a:srgbClr val="FFA657"/>
+                </a:solidFill>
+                <a:effectLst/>
+                <a:latin typeface="Consolas" panose="020B0609020204030204" pitchFamily="49" charset="0"/>
+              </a:rPr>
+              <a:t>name</a:t>
+            </a:r>
+            <a:r>
+              <a:rPr lang="en-US" altLang="ko-KR" sz="1050" b="0">
+                <a:solidFill>
+                  <a:srgbClr val="D4D4D4"/>
+                </a:solidFill>
+                <a:effectLst/>
+                <a:latin typeface="Consolas" panose="020B0609020204030204" pitchFamily="49" charset="0"/>
+              </a:rPr>
+              <a:t>=</a:t>
+            </a:r>
+            <a:r>
+              <a:rPr lang="en-US" altLang="ko-KR" sz="1050" b="0">
+                <a:solidFill>
+                  <a:srgbClr val="A5D6FF"/>
+                </a:solidFill>
+                <a:effectLst/>
+                <a:latin typeface="Consolas" panose="020B0609020204030204" pitchFamily="49" charset="0"/>
+              </a:rPr>
+              <a:t>"ids"</a:t>
+            </a:r>
+            <a:r>
+              <a:rPr lang="en-US" altLang="ko-KR" sz="1050" b="0">
+                <a:solidFill>
+                  <a:srgbClr val="BBBEBF"/>
+                </a:solidFill>
+                <a:effectLst/>
+                <a:latin typeface="Consolas" panose="020B0609020204030204" pitchFamily="49" charset="0"/>
+              </a:rPr>
+              <a:t>) </a:t>
+            </a:r>
+            <a:r>
+              <a:rPr lang="en-US" altLang="ko-KR" sz="1050" b="0">
+                <a:solidFill>
+                  <a:srgbClr val="4EC9B0"/>
+                </a:solidFill>
+                <a:effectLst/>
+                <a:latin typeface="Consolas" panose="020B0609020204030204" pitchFamily="49" charset="0"/>
+              </a:rPr>
+              <a:t>List</a:t>
+            </a:r>
+            <a:r>
+              <a:rPr lang="en-US" altLang="ko-KR" sz="1050" b="0">
+                <a:solidFill>
+                  <a:srgbClr val="BBBEBF"/>
+                </a:solidFill>
+                <a:effectLst/>
+                <a:latin typeface="Consolas" panose="020B0609020204030204" pitchFamily="49" charset="0"/>
+              </a:rPr>
+              <a:t>&lt;</a:t>
+            </a:r>
+            <a:r>
+              <a:rPr lang="en-US" altLang="ko-KR" sz="1050" b="0">
+                <a:solidFill>
+                  <a:srgbClr val="4EC9B0"/>
+                </a:solidFill>
+                <a:effectLst/>
+                <a:latin typeface="Consolas" panose="020B0609020204030204" pitchFamily="49" charset="0"/>
+              </a:rPr>
+              <a:t>Long</a:t>
+            </a:r>
+            <a:r>
+              <a:rPr lang="en-US" altLang="ko-KR" sz="1050" b="0">
+                <a:solidFill>
+                  <a:srgbClr val="BBBEBF"/>
+                </a:solidFill>
+                <a:effectLst/>
+                <a:latin typeface="Consolas" panose="020B0609020204030204" pitchFamily="49" charset="0"/>
+              </a:rPr>
+              <a:t>&gt; </a:t>
+            </a:r>
+            <a:r>
+              <a:rPr lang="en-US" altLang="ko-KR" sz="1050" b="0">
+                <a:solidFill>
+                  <a:srgbClr val="FFA657"/>
+                </a:solidFill>
+                <a:effectLst/>
+                <a:latin typeface="Consolas" panose="020B0609020204030204" pitchFamily="49" charset="0"/>
+              </a:rPr>
+              <a:t>ids</a:t>
+            </a:r>
+            <a:endParaRPr lang="en-US" altLang="ko-KR" sz="1050" b="0">
+              <a:solidFill>
+                <a:srgbClr val="BBBEBF"/>
+              </a:solidFill>
+              <a:effectLst/>
+              <a:latin typeface="Consolas" panose="020B0609020204030204" pitchFamily="49" charset="0"/>
+            </a:endParaRPr>
+          </a:p>
+          <a:p>
+            <a:pPr>
+              <a:lnSpc>
+                <a:spcPts val="1425"/>
+              </a:lnSpc>
+              <a:buNone/>
+            </a:pPr>
+            <a:r>
+              <a:rPr lang="en-US" altLang="ko-KR" sz="1050" b="0">
+                <a:solidFill>
+                  <a:srgbClr val="BBBEBF"/>
+                </a:solidFill>
+                <a:effectLst/>
+                <a:latin typeface="Consolas" panose="020B0609020204030204" pitchFamily="49" charset="0"/>
+              </a:rPr>
+              <a:t>    ) {</a:t>
+            </a:r>
+          </a:p>
+          <a:p>
+            <a:pPr>
+              <a:lnSpc>
+                <a:spcPts val="1425"/>
+              </a:lnSpc>
+              <a:buNone/>
+            </a:pPr>
+            <a:r>
+              <a:rPr lang="en-US" altLang="ko-KR" sz="1050" b="0">
+                <a:solidFill>
+                  <a:srgbClr val="BBBEBF"/>
+                </a:solidFill>
+                <a:effectLst/>
+                <a:latin typeface="Consolas" panose="020B0609020204030204" pitchFamily="49" charset="0"/>
+              </a:rPr>
+              <a:t>        </a:t>
+            </a:r>
+            <a:r>
+              <a:rPr lang="en-US" altLang="ko-KR" sz="1050" b="0">
+                <a:solidFill>
+                  <a:srgbClr val="4EC9B0"/>
+                </a:solidFill>
+                <a:effectLst/>
+                <a:latin typeface="Consolas" panose="020B0609020204030204" pitchFamily="49" charset="0"/>
+              </a:rPr>
+              <a:t>List</a:t>
+            </a:r>
+            <a:r>
+              <a:rPr lang="en-US" altLang="ko-KR" sz="1050" b="0">
+                <a:solidFill>
+                  <a:srgbClr val="FFA657"/>
+                </a:solidFill>
+                <a:effectLst/>
+                <a:latin typeface="Consolas" panose="020B0609020204030204" pitchFamily="49" charset="0"/>
+              </a:rPr>
+              <a:t>&lt;</a:t>
+            </a:r>
+            <a:r>
+              <a:rPr lang="en-US" altLang="ko-KR" sz="1050" b="0">
+                <a:solidFill>
+                  <a:srgbClr val="4EC9B0"/>
+                </a:solidFill>
+                <a:effectLst/>
+                <a:latin typeface="Consolas" panose="020B0609020204030204" pitchFamily="49" charset="0"/>
+              </a:rPr>
+              <a:t>UserResponseDto</a:t>
+            </a:r>
+            <a:r>
+              <a:rPr lang="en-US" altLang="ko-KR" sz="1050" b="0">
+                <a:solidFill>
+                  <a:srgbClr val="FFA657"/>
+                </a:solidFill>
+                <a:effectLst/>
+                <a:latin typeface="Consolas" panose="020B0609020204030204" pitchFamily="49" charset="0"/>
+              </a:rPr>
+              <a:t>&gt; </a:t>
+            </a:r>
+            <a:r>
+              <a:rPr lang="en-US" altLang="ko-KR" sz="1050" b="0">
+                <a:solidFill>
+                  <a:srgbClr val="C9D1D9"/>
+                </a:solidFill>
+                <a:effectLst/>
+                <a:latin typeface="Consolas" panose="020B0609020204030204" pitchFamily="49" charset="0"/>
+              </a:rPr>
+              <a:t>userResponseDtos</a:t>
+            </a:r>
+            <a:r>
+              <a:rPr lang="en-US" altLang="ko-KR" sz="1050" b="0">
+                <a:solidFill>
+                  <a:srgbClr val="FFA657"/>
+                </a:solidFill>
+                <a:effectLst/>
+                <a:latin typeface="Consolas" panose="020B0609020204030204" pitchFamily="49" charset="0"/>
+              </a:rPr>
+              <a:t> </a:t>
+            </a:r>
+            <a:r>
+              <a:rPr lang="en-US" altLang="ko-KR" sz="1050" b="0">
+                <a:solidFill>
+                  <a:srgbClr val="D4D4D4"/>
+                </a:solidFill>
+                <a:effectLst/>
+                <a:latin typeface="Consolas" panose="020B0609020204030204" pitchFamily="49" charset="0"/>
+              </a:rPr>
+              <a:t>=</a:t>
+            </a:r>
+            <a:r>
+              <a:rPr lang="en-US" altLang="ko-KR" sz="1050" b="0">
+                <a:solidFill>
+                  <a:srgbClr val="BBBEBF"/>
+                </a:solidFill>
+                <a:effectLst/>
+                <a:latin typeface="Consolas" panose="020B0609020204030204" pitchFamily="49" charset="0"/>
+              </a:rPr>
+              <a:t> </a:t>
+            </a:r>
+            <a:r>
+              <a:rPr lang="en-US" altLang="ko-KR" sz="1050" b="0">
+                <a:solidFill>
+                  <a:srgbClr val="79C0FF"/>
+                </a:solidFill>
+                <a:effectLst/>
+                <a:latin typeface="Consolas" panose="020B0609020204030204" pitchFamily="49" charset="0"/>
+              </a:rPr>
+              <a:t>userService</a:t>
+            </a:r>
+            <a:r>
+              <a:rPr lang="en-US" altLang="ko-KR" sz="1050" b="0">
+                <a:solidFill>
+                  <a:srgbClr val="BBBEBF"/>
+                </a:solidFill>
+                <a:effectLst/>
+                <a:latin typeface="Consolas" panose="020B0609020204030204" pitchFamily="49" charset="0"/>
+              </a:rPr>
+              <a:t>.</a:t>
+            </a:r>
+            <a:r>
+              <a:rPr lang="en-US" altLang="ko-KR" sz="1050" b="0">
+                <a:solidFill>
+                  <a:srgbClr val="D2A8FF"/>
+                </a:solidFill>
+                <a:effectLst/>
+                <a:latin typeface="Consolas" panose="020B0609020204030204" pitchFamily="49" charset="0"/>
+              </a:rPr>
+              <a:t>getUsersByIds</a:t>
+            </a:r>
+            <a:r>
+              <a:rPr lang="en-US" altLang="ko-KR" sz="1050" b="0">
+                <a:solidFill>
+                  <a:srgbClr val="BBBEBF"/>
+                </a:solidFill>
+                <a:effectLst/>
+                <a:latin typeface="Consolas" panose="020B0609020204030204" pitchFamily="49" charset="0"/>
+              </a:rPr>
+              <a:t>(</a:t>
+            </a:r>
+            <a:r>
+              <a:rPr lang="en-US" altLang="ko-KR" sz="1050" b="0">
+                <a:solidFill>
+                  <a:srgbClr val="FFA657"/>
+                </a:solidFill>
+                <a:effectLst/>
+                <a:latin typeface="Consolas" panose="020B0609020204030204" pitchFamily="49" charset="0"/>
+              </a:rPr>
+              <a:t>ids</a:t>
+            </a:r>
+            <a:r>
+              <a:rPr lang="en-US" altLang="ko-KR" sz="1050" b="0">
+                <a:solidFill>
+                  <a:srgbClr val="BBBEBF"/>
+                </a:solidFill>
+                <a:effectLst/>
+                <a:latin typeface="Consolas" panose="020B0609020204030204" pitchFamily="49" charset="0"/>
+              </a:rPr>
+              <a:t>);</a:t>
+            </a:r>
+          </a:p>
+          <a:p>
+            <a:pPr>
+              <a:lnSpc>
+                <a:spcPts val="1425"/>
+              </a:lnSpc>
+              <a:buNone/>
+            </a:pPr>
+            <a:r>
+              <a:rPr lang="en-US" altLang="ko-KR" sz="1050" b="0">
+                <a:solidFill>
+                  <a:srgbClr val="BBBEBF"/>
+                </a:solidFill>
+                <a:effectLst/>
+                <a:latin typeface="Consolas" panose="020B0609020204030204" pitchFamily="49" charset="0"/>
+              </a:rPr>
+              <a:t>        </a:t>
+            </a:r>
+            <a:r>
+              <a:rPr lang="en-US" altLang="ko-KR" sz="1050" b="0">
+                <a:solidFill>
+                  <a:srgbClr val="C586C0"/>
+                </a:solidFill>
+                <a:effectLst/>
+                <a:latin typeface="Consolas" panose="020B0609020204030204" pitchFamily="49" charset="0"/>
+              </a:rPr>
+              <a:t>return</a:t>
+            </a:r>
+            <a:r>
+              <a:rPr lang="en-US" altLang="ko-KR" sz="1050" b="0">
+                <a:solidFill>
+                  <a:srgbClr val="BBBEBF"/>
+                </a:solidFill>
+                <a:effectLst/>
+                <a:latin typeface="Consolas" panose="020B0609020204030204" pitchFamily="49" charset="0"/>
+              </a:rPr>
+              <a:t> </a:t>
+            </a:r>
+            <a:r>
+              <a:rPr lang="en-US" altLang="ko-KR" sz="1050" b="0">
+                <a:solidFill>
+                  <a:srgbClr val="4EC9B0"/>
+                </a:solidFill>
+                <a:effectLst/>
+                <a:latin typeface="Consolas" panose="020B0609020204030204" pitchFamily="49" charset="0"/>
+              </a:rPr>
+              <a:t>ResponseEntity</a:t>
+            </a:r>
+            <a:r>
+              <a:rPr lang="en-US" altLang="ko-KR" sz="1050" b="0">
+                <a:solidFill>
+                  <a:srgbClr val="BBBEBF"/>
+                </a:solidFill>
+                <a:effectLst/>
+                <a:latin typeface="Consolas" panose="020B0609020204030204" pitchFamily="49" charset="0"/>
+              </a:rPr>
+              <a:t>.</a:t>
+            </a:r>
+            <a:r>
+              <a:rPr lang="en-US" altLang="ko-KR" sz="1050" b="0">
+                <a:solidFill>
+                  <a:srgbClr val="D2A8FF"/>
+                </a:solidFill>
+                <a:effectLst/>
+                <a:latin typeface="Consolas" panose="020B0609020204030204" pitchFamily="49" charset="0"/>
+              </a:rPr>
+              <a:t>ok</a:t>
+            </a:r>
+            <a:r>
+              <a:rPr lang="en-US" altLang="ko-KR" sz="1050" b="0">
+                <a:solidFill>
+                  <a:srgbClr val="BBBEBF"/>
+                </a:solidFill>
+                <a:effectLst/>
+                <a:latin typeface="Consolas" panose="020B0609020204030204" pitchFamily="49" charset="0"/>
+              </a:rPr>
+              <a:t>(</a:t>
+            </a:r>
+            <a:r>
+              <a:rPr lang="en-US" altLang="ko-KR" sz="1050" b="0">
+                <a:solidFill>
+                  <a:srgbClr val="C9D1D9"/>
+                </a:solidFill>
+                <a:effectLst/>
+                <a:latin typeface="Consolas" panose="020B0609020204030204" pitchFamily="49" charset="0"/>
+              </a:rPr>
+              <a:t>userResponseDtos</a:t>
+            </a:r>
+            <a:r>
+              <a:rPr lang="en-US" altLang="ko-KR" sz="1050" b="0">
+                <a:solidFill>
+                  <a:srgbClr val="BBBEBF"/>
+                </a:solidFill>
+                <a:effectLst/>
+                <a:latin typeface="Consolas" panose="020B0609020204030204" pitchFamily="49" charset="0"/>
+              </a:rPr>
+              <a:t>);</a:t>
+            </a:r>
+          </a:p>
+          <a:p>
+            <a:pPr>
+              <a:lnSpc>
+                <a:spcPts val="1425"/>
+              </a:lnSpc>
+              <a:buNone/>
+            </a:pPr>
+            <a:r>
+              <a:rPr lang="en-US" altLang="ko-KR" sz="1050" b="0">
+                <a:solidFill>
+                  <a:srgbClr val="BBBEBF"/>
+                </a:solidFill>
+                <a:effectLst/>
+                <a:latin typeface="Consolas" panose="020B0609020204030204" pitchFamily="49" charset="0"/>
+              </a:rPr>
+              <a:t>    }</a:t>
+            </a:r>
+          </a:p>
+        </p:txBody>
+      </p:sp>
+    </p:spTree>
+    <p:extLst>
+      <p:ext uri="{BB962C8B-B14F-4D97-AF65-F5344CB8AC3E}">
+        <p14:creationId xmlns:p14="http://schemas.microsoft.com/office/powerpoint/2010/main" val="2266387346"/>
+      </p:ext>
+    </p:extLst>
+  </p:cSld>
+  <p:clrMapOvr>
+    <a:masterClrMapping/>
+  </p:clrMapOvr>
+</p:sld>
+</file>
+
+<file path=ppt/slides/slide27.xml><?xml version="1.0" encoding="utf-8"?>
+<p:sld xmlns:a="http://schemas.openxmlformats.org/drawingml/2006/main" xmlns:r="http://schemas.openxmlformats.org/officeDocument/2006/relationships" xmlns:p="http://schemas.openxmlformats.org/presentationml/2006/main">
+  <p:cSld>
+    <p:spTree>
+      <p:nvGrpSpPr>
+        <p:cNvPr id="1" name=""/>
+        <p:cNvGrpSpPr/>
+        <p:nvPr/>
+      </p:nvGrpSpPr>
+      <p:grpSpPr>
+        <a:xfrm>
+          <a:off x="0" y="0"/>
+          <a:ext cx="0" cy="0"/>
+          <a:chOff x="0" y="0"/>
+          <a:chExt cx="0" cy="0"/>
+        </a:xfrm>
+      </p:grpSpPr>
+      <p:sp>
+        <p:nvSpPr>
+          <p:cNvPr id="2" name="제목 1">
+            <a:extLst>
+              <a:ext uri="{FF2B5EF4-FFF2-40B4-BE49-F238E27FC236}">
+                <a16:creationId xmlns:a16="http://schemas.microsoft.com/office/drawing/2014/main" id="{A13FDF1A-4B7D-6E25-F755-B75CDE149666}"/>
+              </a:ext>
+            </a:extLst>
+          </p:cNvPr>
+          <p:cNvSpPr>
+            <a:spLocks noGrp="1"/>
+          </p:cNvSpPr>
+          <p:nvPr>
+            <p:ph type="title"/>
+          </p:nvPr>
+        </p:nvSpPr>
+        <p:spPr/>
+        <p:txBody>
+          <a:bodyPr/>
+          <a:lstStyle/>
+          <a:p>
+            <a:r>
+              <a:rPr lang="ko-KR" altLang="en-US"/>
+              <a:t>회원</a:t>
+            </a:r>
+            <a:r>
+              <a:rPr lang="en-US" altLang="ko-KR"/>
+              <a:t>Ids </a:t>
+            </a:r>
+            <a:r>
+              <a:rPr lang="ko-KR" altLang="en-US"/>
+              <a:t>조회 테스트</a:t>
+            </a:r>
+          </a:p>
+        </p:txBody>
+      </p:sp>
+      <p:pic>
+        <p:nvPicPr>
+          <p:cNvPr id="4" name="그림 3">
+            <a:extLst>
+              <a:ext uri="{FF2B5EF4-FFF2-40B4-BE49-F238E27FC236}">
+                <a16:creationId xmlns:a16="http://schemas.microsoft.com/office/drawing/2014/main" id="{167DD790-E2F3-C4AC-B26E-3301DC1B33B1}"/>
+              </a:ext>
+            </a:extLst>
+          </p:cNvPr>
+          <p:cNvPicPr>
+            <a:picLocks noChangeAspect="1"/>
+          </p:cNvPicPr>
+          <p:nvPr/>
+        </p:nvPicPr>
+        <p:blipFill>
+          <a:blip r:embed="rId2"/>
+          <a:stretch>
+            <a:fillRect/>
+          </a:stretch>
+        </p:blipFill>
+        <p:spPr>
+          <a:xfrm>
+            <a:off x="1097280" y="1910936"/>
+            <a:ext cx="7297168" cy="2286319"/>
+          </a:xfrm>
+          <a:prstGeom prst="rect">
+            <a:avLst/>
+          </a:prstGeom>
+        </p:spPr>
+      </p:pic>
+      <p:pic>
+        <p:nvPicPr>
+          <p:cNvPr id="6" name="그림 5">
+            <a:extLst>
+              <a:ext uri="{FF2B5EF4-FFF2-40B4-BE49-F238E27FC236}">
+                <a16:creationId xmlns:a16="http://schemas.microsoft.com/office/drawing/2014/main" id="{1947B4D4-95FF-3ABC-D615-59C2E8C162B8}"/>
+              </a:ext>
+            </a:extLst>
+          </p:cNvPr>
+          <p:cNvPicPr>
+            <a:picLocks noChangeAspect="1"/>
+          </p:cNvPicPr>
+          <p:nvPr/>
+        </p:nvPicPr>
+        <p:blipFill>
+          <a:blip r:embed="rId3"/>
+          <a:stretch>
+            <a:fillRect/>
+          </a:stretch>
+        </p:blipFill>
+        <p:spPr>
+          <a:xfrm>
+            <a:off x="1097280" y="4370831"/>
+            <a:ext cx="8840434" cy="1257475"/>
+          </a:xfrm>
+          <a:prstGeom prst="rect">
+            <a:avLst/>
+          </a:prstGeom>
+        </p:spPr>
+      </p:pic>
+    </p:spTree>
+    <p:extLst>
+      <p:ext uri="{BB962C8B-B14F-4D97-AF65-F5344CB8AC3E}">
+        <p14:creationId xmlns:p14="http://schemas.microsoft.com/office/powerpoint/2010/main" val="2626242844"/>
+      </p:ext>
+    </p:extLst>
+  </p:cSld>
+  <p:clrMapOvr>
+    <a:masterClrMapping/>
+  </p:clrMapOvr>
+</p:sld>
+</file>
+
 <file path=ppt/slides/slide3.xml><?xml version="1.0" encoding="utf-8"?>
 <p:sld xmlns:a="http://schemas.openxmlformats.org/drawingml/2006/main" xmlns:r="http://schemas.openxmlformats.org/officeDocument/2006/relationships" xmlns:p="http://schemas.openxmlformats.org/presentationml/2006/main">
   <p:cSld>

</xml_diff>